<commit_message>
docs(presentation): finalize SIH26159 national submission deck
Rebuild the six-slide deck on the official template with every figure
re-measured against this working tree rather than carried forward.

The metric tiles now read 1,357 backend tests, 1,367 with the TShark
cross-check, 89 frontend tests, 5 real-backend end-to-end specs, 158
files clean under ruff and mypy, and 0 known advisories. Each of those
was produced by running the gate, not by editing the number.

Slide 6 carries the repository link and a QR code that was decoded
independently with zbarimg and resolves to the public repository.

Co-Authored-By: Claude Opus 5 <noreply@anthropic.com>
</commit_message>
<xml_diff>
--- a/submission/final/SecureMailScope-SIH26159-Zero-Day.pptx
+++ b/submission/final/SecureMailScope-SIH26159-Zero-Day.pptx
@@ -6705,7 +6705,7 @@
                 </a:solidFill>
                 <a:latin typeface="Calibri"/>
               </a:rPr>
-              <a:t>STARTTLS / TLS</a:t>
+              <a:t>STARTTLS · STLS · TLS</a:t>
             </a:r>
           </a:p>
           <a:p>
@@ -7507,7 +7507,7 @@
                 </a:solidFill>
                 <a:latin typeface="Calibri"/>
               </a:rPr>
-              <a:t>One direction of flow. Each stage reads only what the previous one produced, and records the packets it read it from.</a:t>
+              <a:t>Each stage consumes the previous stage’s evidence and preserves packet-level provenance.</a:t>
             </a:r>
           </a:p>
         </p:txBody>
@@ -11641,7 +11641,7 @@
                 </a:solidFill>
                 <a:latin typeface="Calibri"/>
               </a:rPr>
-              <a:t>156</a:t>
+              <a:t>158</a:t>
             </a:r>
           </a:p>
           <a:p>
@@ -15594,7 +15594,7 @@
                 </a:solidFill>
                 <a:latin typeface="Calibri"/>
               </a:rPr>
-              <a:t>Demonstration  </a:t>
+              <a:t>Demonstration video  </a:t>
             </a:r>
             <a:r>
               <a:rPr sz="1200" i="1">
@@ -15603,7 +15603,7 @@
                 </a:solidFill>
                 <a:latin typeface="Calibri"/>
               </a:rPr>
-              <a:t>Demo video included in submission package.</a:t>
+              <a:t>Included in the submission package.</a:t>
             </a:r>
           </a:p>
         </p:txBody>
@@ -15753,7 +15753,7 @@
                 </a:solidFill>
                 <a:latin typeface="Calibri"/>
               </a:rPr>
-              <a:t>Private until the team publishes it.</a:t>
+              <a:t>Public repository — source, tests and submission package.</a:t>
             </a:r>
           </a:p>
         </p:txBody>

</xml_diff>

<commit_message>
docs(presentation): size the architecture type for a projected room
The technical-approach diagram carried its supporting lines at 7.5 pt,
which is legible on a laptop and not from a seat. Node titles are now
10 pt and their detail lines 8.5 pt, with the architecture region and
every stack recomputed around the larger type rather than the type being
squeezed into the old boxes.

Rendering that change showed three band labels struck through by the
first node of their own stack, so the label strip inside a band is now a
named constant the stacks are laid out beneath. All six pages were
re-rendered and checked afterwards.

Co-Authored-By: Claude Opus 5 <noreply@anthropic.com>
</commit_message>
<xml_diff>
--- a/submission/final/SecureMailScope-SIH26159-Zero-Day.pptx
+++ b/submission/final/SecureMailScope-SIH26159-Zero-Day.pptx
@@ -7673,7 +7673,7 @@
         <p:spPr>
           <a:xfrm>
             <a:off x="384048" y="1335024"/>
-            <a:ext cx="1793737" cy="2743200"/>
+            <a:ext cx="1793737" cy="2962656"/>
           </a:xfrm>
           <a:prstGeom prst="roundRect">
             <a:avLst/>
@@ -7716,7 +7716,7 @@
               <a:buNone/>
             </a:pPr>
             <a:r>
-              <a:rPr sz="750" b="1">
+              <a:rPr sz="800" b="1">
                 <a:solidFill>
                   <a:srgbClr val="8A9BB0"/>
                 </a:solidFill>
@@ -7735,8 +7735,8 @@
         </p:nvSpPr>
         <p:spPr>
           <a:xfrm>
-            <a:off x="475488" y="2039111"/>
-            <a:ext cx="1610857" cy="676656"/>
+            <a:off x="475488" y="2093976"/>
+            <a:ext cx="1610857" cy="768096"/>
           </a:xfrm>
           <a:prstGeom prst="roundRect">
             <a:avLst/>
@@ -7779,7 +7779,7 @@
               <a:buNone/>
             </a:pPr>
             <a:r>
-              <a:rPr sz="950" b="1">
+              <a:rPr sz="1000" b="1">
                 <a:solidFill>
                   <a:srgbClr val="111B2A"/>
                 </a:solidFill>
@@ -7799,7 +7799,7 @@
               <a:buNone/>
             </a:pPr>
             <a:r>
-              <a:rPr sz="750" b="0">
+              <a:rPr sz="850" b="0">
                 <a:solidFill>
                   <a:srgbClr val="4A5A70"/>
                 </a:solidFill>
@@ -7818,7 +7818,7 @@
         </p:nvSpPr>
         <p:spPr>
           <a:xfrm>
-            <a:off x="1198620" y="2724911"/>
+            <a:off x="1198620" y="2871215"/>
             <a:ext cx="164592" cy="109728"/>
           </a:xfrm>
           <a:prstGeom prst="downArrow">
@@ -7862,8 +7862,8 @@
         </p:nvSpPr>
         <p:spPr>
           <a:xfrm>
-            <a:off x="475488" y="2843784"/>
-            <a:ext cx="1610857" cy="676656"/>
+            <a:off x="475488" y="2990088"/>
+            <a:ext cx="1610857" cy="768096"/>
           </a:xfrm>
           <a:prstGeom prst="roundRect">
             <a:avLst/>
@@ -7906,7 +7906,7 @@
               <a:buNone/>
             </a:pPr>
             <a:r>
-              <a:rPr sz="950" b="1">
+              <a:rPr sz="1000" b="1">
                 <a:solidFill>
                   <a:srgbClr val="111B2A"/>
                 </a:solidFill>
@@ -7926,7 +7926,7 @@
               <a:buNone/>
             </a:pPr>
             <a:r>
-              <a:rPr sz="750" b="0">
+              <a:rPr sz="850" b="0">
                 <a:solidFill>
                   <a:srgbClr val="4A5A70"/>
                 </a:solidFill>
@@ -7946,7 +7946,7 @@
         <p:spPr>
           <a:xfrm>
             <a:off x="2324089" y="1335024"/>
-            <a:ext cx="2196413" cy="2743200"/>
+            <a:ext cx="2196413" cy="2962656"/>
           </a:xfrm>
           <a:prstGeom prst="roundRect">
             <a:avLst/>
@@ -7989,7 +7989,7 @@
               <a:buNone/>
             </a:pPr>
             <a:r>
-              <a:rPr sz="750" b="1">
+              <a:rPr sz="800" b="1">
                 <a:solidFill>
                   <a:srgbClr val="8A9BB0"/>
                 </a:solidFill>
@@ -8008,8 +8008,8 @@
         </p:nvSpPr>
         <p:spPr>
           <a:xfrm>
-            <a:off x="2415529" y="1636775"/>
-            <a:ext cx="2013533" cy="475488"/>
+            <a:off x="2415529" y="1673352"/>
+            <a:ext cx="2013533" cy="530352"/>
           </a:xfrm>
           <a:prstGeom prst="roundRect">
             <a:avLst/>
@@ -8052,7 +8052,7 @@
               <a:buNone/>
             </a:pPr>
             <a:r>
-              <a:rPr sz="950" b="1">
+              <a:rPr sz="1000" b="1">
                 <a:solidFill>
                   <a:srgbClr val="111B2A"/>
                 </a:solidFill>
@@ -8071,7 +8071,7 @@
         </p:nvSpPr>
         <p:spPr>
           <a:xfrm>
-            <a:off x="3340000" y="2121407"/>
+            <a:off x="3340000" y="2212848"/>
             <a:ext cx="164592" cy="109728"/>
           </a:xfrm>
           <a:prstGeom prst="downArrow">
@@ -8115,8 +8115,8 @@
         </p:nvSpPr>
         <p:spPr>
           <a:xfrm>
-            <a:off x="2415529" y="2240279"/>
-            <a:ext cx="2013533" cy="475488"/>
+            <a:off x="2415529" y="2331720"/>
+            <a:ext cx="2013533" cy="530352"/>
           </a:xfrm>
           <a:prstGeom prst="roundRect">
             <a:avLst/>
@@ -8159,7 +8159,7 @@
               <a:buNone/>
             </a:pPr>
             <a:r>
-              <a:rPr sz="950" b="1">
+              <a:rPr sz="1000" b="1">
                 <a:solidFill>
                   <a:srgbClr val="111B2A"/>
                 </a:solidFill>
@@ -8179,7 +8179,7 @@
               <a:buNone/>
             </a:pPr>
             <a:r>
-              <a:rPr sz="750" b="0">
+              <a:rPr sz="850" b="0">
                 <a:solidFill>
                   <a:srgbClr val="4A5A70"/>
                 </a:solidFill>
@@ -8198,7 +8198,7 @@
         </p:nvSpPr>
         <p:spPr>
           <a:xfrm>
-            <a:off x="3340000" y="2724911"/>
+            <a:off x="3340000" y="2871216"/>
             <a:ext cx="164592" cy="109728"/>
           </a:xfrm>
           <a:prstGeom prst="downArrow">
@@ -8242,8 +8242,8 @@
         </p:nvSpPr>
         <p:spPr>
           <a:xfrm>
-            <a:off x="2415529" y="2843784"/>
-            <a:ext cx="2013533" cy="475488"/>
+            <a:off x="2415529" y="2990088"/>
+            <a:ext cx="2013533" cy="530352"/>
           </a:xfrm>
           <a:prstGeom prst="roundRect">
             <a:avLst/>
@@ -8286,7 +8286,7 @@
               <a:buNone/>
             </a:pPr>
             <a:r>
-              <a:rPr sz="950" b="1">
+              <a:rPr sz="1000" b="1">
                 <a:solidFill>
                   <a:srgbClr val="111B2A"/>
                 </a:solidFill>
@@ -8306,7 +8306,7 @@
               <a:buNone/>
             </a:pPr>
             <a:r>
-              <a:rPr sz="750" b="0">
+              <a:rPr sz="850" b="0">
                 <a:solidFill>
                   <a:srgbClr val="4A5A70"/>
                 </a:solidFill>
@@ -8325,7 +8325,7 @@
         </p:nvSpPr>
         <p:spPr>
           <a:xfrm>
-            <a:off x="3340000" y="3328415"/>
+            <a:off x="3340000" y="3529584"/>
             <a:ext cx="164592" cy="109728"/>
           </a:xfrm>
           <a:prstGeom prst="downArrow">
@@ -8369,8 +8369,8 @@
         </p:nvSpPr>
         <p:spPr>
           <a:xfrm>
-            <a:off x="2415529" y="3447288"/>
-            <a:ext cx="2013533" cy="475488"/>
+            <a:off x="2415529" y="3648456"/>
+            <a:ext cx="2013533" cy="530352"/>
           </a:xfrm>
           <a:prstGeom prst="roundRect">
             <a:avLst/>
@@ -8413,7 +8413,7 @@
               <a:buNone/>
             </a:pPr>
             <a:r>
-              <a:rPr sz="950" b="1">
+              <a:rPr sz="1000" b="1">
                 <a:solidFill>
                   <a:srgbClr val="111B2A"/>
                 </a:solidFill>
@@ -8433,7 +8433,7 @@
               <a:buNone/>
             </a:pPr>
             <a:r>
-              <a:rPr sz="750" b="0">
+              <a:rPr sz="850" b="0">
                 <a:solidFill>
                   <a:srgbClr val="4A5A70"/>
                 </a:solidFill>
@@ -8453,7 +8453,7 @@
         <p:spPr>
           <a:xfrm>
             <a:off x="4666807" y="1335024"/>
-            <a:ext cx="2269627" cy="2743200"/>
+            <a:ext cx="2269627" cy="2962656"/>
           </a:xfrm>
           <a:prstGeom prst="roundRect">
             <a:avLst/>
@@ -8496,7 +8496,7 @@
               <a:buNone/>
             </a:pPr>
             <a:r>
-              <a:rPr sz="750" b="1">
+              <a:rPr sz="800" b="1">
                 <a:solidFill>
                   <a:srgbClr val="8A9BB0"/>
                 </a:solidFill>
@@ -8515,8 +8515,8 @@
         </p:nvSpPr>
         <p:spPr>
           <a:xfrm>
-            <a:off x="4758247" y="1636775"/>
-            <a:ext cx="2086747" cy="475488"/>
+            <a:off x="4758247" y="1673352"/>
+            <a:ext cx="2086747" cy="530352"/>
           </a:xfrm>
           <a:prstGeom prst="roundRect">
             <a:avLst/>
@@ -8559,7 +8559,7 @@
               <a:buNone/>
             </a:pPr>
             <a:r>
-              <a:rPr sz="950" b="1">
+              <a:rPr sz="1000" b="1">
                 <a:solidFill>
                   <a:srgbClr val="111B2A"/>
                 </a:solidFill>
@@ -8579,7 +8579,7 @@
               <a:buNone/>
             </a:pPr>
             <a:r>
-              <a:rPr sz="750" b="0">
+              <a:rPr sz="850" b="0">
                 <a:solidFill>
                   <a:srgbClr val="4A5A70"/>
                 </a:solidFill>
@@ -8598,7 +8598,7 @@
         </p:nvSpPr>
         <p:spPr>
           <a:xfrm>
-            <a:off x="5719324" y="2121407"/>
+            <a:off x="5719324" y="2212848"/>
             <a:ext cx="164592" cy="109728"/>
           </a:xfrm>
           <a:prstGeom prst="downArrow">
@@ -8642,8 +8642,8 @@
         </p:nvSpPr>
         <p:spPr>
           <a:xfrm>
-            <a:off x="4758247" y="2240279"/>
-            <a:ext cx="2086747" cy="475488"/>
+            <a:off x="4758247" y="2331720"/>
+            <a:ext cx="2086747" cy="530352"/>
           </a:xfrm>
           <a:prstGeom prst="roundRect">
             <a:avLst/>
@@ -8686,7 +8686,7 @@
               <a:buNone/>
             </a:pPr>
             <a:r>
-              <a:rPr sz="950" b="1">
+              <a:rPr sz="1000" b="1">
                 <a:solidFill>
                   <a:srgbClr val="111B2A"/>
                 </a:solidFill>
@@ -8706,7 +8706,7 @@
               <a:buNone/>
             </a:pPr>
             <a:r>
-              <a:rPr sz="750" b="0">
+              <a:rPr sz="850" b="0">
                 <a:solidFill>
                   <a:srgbClr val="4A5A70"/>
                 </a:solidFill>
@@ -8725,7 +8725,7 @@
         </p:nvSpPr>
         <p:spPr>
           <a:xfrm>
-            <a:off x="5719324" y="2724911"/>
+            <a:off x="5719324" y="2871216"/>
             <a:ext cx="164592" cy="109728"/>
           </a:xfrm>
           <a:prstGeom prst="downArrow">
@@ -8769,8 +8769,8 @@
         </p:nvSpPr>
         <p:spPr>
           <a:xfrm>
-            <a:off x="4758247" y="2843784"/>
-            <a:ext cx="2086747" cy="475488"/>
+            <a:off x="4758247" y="2990088"/>
+            <a:ext cx="2086747" cy="530352"/>
           </a:xfrm>
           <a:prstGeom prst="roundRect">
             <a:avLst/>
@@ -8813,7 +8813,7 @@
               <a:buNone/>
             </a:pPr>
             <a:r>
-              <a:rPr sz="950" b="1">
+              <a:rPr sz="1000" b="1">
                 <a:solidFill>
                   <a:srgbClr val="111B2A"/>
                 </a:solidFill>
@@ -8833,7 +8833,7 @@
               <a:buNone/>
             </a:pPr>
             <a:r>
-              <a:rPr sz="750" b="0">
+              <a:rPr sz="850" b="0">
                 <a:solidFill>
                   <a:srgbClr val="4A5A70"/>
                 </a:solidFill>
@@ -8852,7 +8852,7 @@
         </p:nvSpPr>
         <p:spPr>
           <a:xfrm>
-            <a:off x="5719324" y="3328415"/>
+            <a:off x="5719324" y="3529584"/>
             <a:ext cx="164592" cy="109728"/>
           </a:xfrm>
           <a:prstGeom prst="downArrow">
@@ -8896,8 +8896,8 @@
         </p:nvSpPr>
         <p:spPr>
           <a:xfrm>
-            <a:off x="4758247" y="3447288"/>
-            <a:ext cx="2086747" cy="475488"/>
+            <a:off x="4758247" y="3648456"/>
+            <a:ext cx="2086747" cy="530352"/>
           </a:xfrm>
           <a:prstGeom prst="roundRect">
             <a:avLst/>
@@ -8940,7 +8940,7 @@
               <a:buNone/>
             </a:pPr>
             <a:r>
-              <a:rPr sz="950" b="1">
+              <a:rPr sz="1000" b="1">
                 <a:solidFill>
                   <a:srgbClr val="111B2A"/>
                 </a:solidFill>
@@ -8960,7 +8960,7 @@
               <a:buNone/>
             </a:pPr>
             <a:r>
-              <a:rPr sz="750" b="0">
+              <a:rPr sz="850" b="0">
                 <a:solidFill>
                   <a:srgbClr val="4A5A70"/>
                 </a:solidFill>
@@ -8980,7 +8980,7 @@
         <p:spPr>
           <a:xfrm>
             <a:off x="7082738" y="1335024"/>
-            <a:ext cx="2489268" cy="1115568"/>
+            <a:ext cx="2489268" cy="1152144"/>
           </a:xfrm>
           <a:prstGeom prst="roundRect">
             <a:avLst/>
@@ -9023,7 +9023,7 @@
               <a:buNone/>
             </a:pPr>
             <a:r>
-              <a:rPr sz="750" b="1">
+              <a:rPr sz="800" b="1">
                 <a:solidFill>
                   <a:srgbClr val="8A9BB0"/>
                 </a:solidFill>
@@ -9042,7 +9042,7 @@
         </p:nvSpPr>
         <p:spPr>
           <a:xfrm>
-            <a:off x="7174178" y="1545336"/>
+            <a:off x="7174178" y="1618488"/>
             <a:ext cx="2306388" cy="237744"/>
           </a:xfrm>
           <a:prstGeom prst="roundRect">
@@ -9086,7 +9086,7 @@
               <a:buNone/>
             </a:pPr>
             <a:r>
-              <a:rPr sz="950" b="1">
+              <a:rPr sz="1000" b="1">
                 <a:solidFill>
                   <a:srgbClr val="111B2A"/>
                 </a:solidFill>
@@ -9105,8 +9105,8 @@
         </p:nvSpPr>
         <p:spPr>
           <a:xfrm>
-            <a:off x="8245076" y="1792224"/>
-            <a:ext cx="164592" cy="54864"/>
+            <a:off x="8245076" y="1865376"/>
+            <a:ext cx="164592" cy="45720"/>
           </a:xfrm>
           <a:prstGeom prst="downArrow">
             <a:avLst/>
@@ -9149,7 +9149,7 @@
         </p:nvSpPr>
         <p:spPr>
           <a:xfrm>
-            <a:off x="7174178" y="1856231"/>
+            <a:off x="7174178" y="1920240"/>
             <a:ext cx="2306388" cy="237744"/>
           </a:xfrm>
           <a:prstGeom prst="roundRect">
@@ -9193,7 +9193,7 @@
               <a:buNone/>
             </a:pPr>
             <a:r>
-              <a:rPr sz="950" b="1">
+              <a:rPr sz="1000" b="1">
                 <a:solidFill>
                   <a:srgbClr val="111B2A"/>
                 </a:solidFill>
@@ -9212,8 +9212,8 @@
         </p:nvSpPr>
         <p:spPr>
           <a:xfrm>
-            <a:off x="8245076" y="2103120"/>
-            <a:ext cx="164592" cy="54864"/>
+            <a:off x="8245076" y="2167128"/>
+            <a:ext cx="164592" cy="45720"/>
           </a:xfrm>
           <a:prstGeom prst="downArrow">
             <a:avLst/>
@@ -9256,7 +9256,7 @@
         </p:nvSpPr>
         <p:spPr>
           <a:xfrm>
-            <a:off x="7174178" y="2167128"/>
+            <a:off x="7174178" y="2221992"/>
             <a:ext cx="2306388" cy="237744"/>
           </a:xfrm>
           <a:prstGeom prst="roundRect">
@@ -9300,7 +9300,7 @@
               <a:buNone/>
             </a:pPr>
             <a:r>
-              <a:rPr sz="950" b="1">
+              <a:rPr sz="1000" b="1">
                 <a:solidFill>
                   <a:srgbClr val="111B2A"/>
                 </a:solidFill>
@@ -9319,8 +9319,8 @@
         </p:nvSpPr>
         <p:spPr>
           <a:xfrm>
-            <a:off x="7082738" y="2542032"/>
-            <a:ext cx="2489268" cy="1536192"/>
+            <a:off x="7082738" y="2578608"/>
+            <a:ext cx="2489268" cy="1719072"/>
           </a:xfrm>
           <a:prstGeom prst="roundRect">
             <a:avLst/>
@@ -9363,7 +9363,7 @@
               <a:buNone/>
             </a:pPr>
             <a:r>
-              <a:rPr sz="800" b="1">
+              <a:rPr sz="850" b="1">
                 <a:solidFill>
                   <a:srgbClr val="A83A1E"/>
                 </a:solidFill>
@@ -9382,8 +9382,8 @@
         </p:nvSpPr>
         <p:spPr>
           <a:xfrm>
-            <a:off x="7174178" y="2779775"/>
-            <a:ext cx="2306388" cy="274320"/>
+            <a:off x="7174178" y="2871215"/>
+            <a:ext cx="2306388" cy="347472"/>
           </a:xfrm>
           <a:prstGeom prst="roundRect">
             <a:avLst/>
@@ -9426,7 +9426,7 @@
               <a:buNone/>
             </a:pPr>
             <a:r>
-              <a:rPr sz="950" b="1">
+              <a:rPr sz="1000" b="1">
                 <a:solidFill>
                   <a:srgbClr val="111B2A"/>
                 </a:solidFill>
@@ -9446,7 +9446,7 @@
               <a:buNone/>
             </a:pPr>
             <a:r>
-              <a:rPr sz="750" b="0">
+              <a:rPr sz="850" b="0">
                 <a:solidFill>
                   <a:srgbClr val="4A5A70"/>
                 </a:solidFill>
@@ -9465,8 +9465,8 @@
         </p:nvSpPr>
         <p:spPr>
           <a:xfrm>
-            <a:off x="8245076" y="3063239"/>
-            <a:ext cx="164592" cy="54864"/>
+            <a:off x="8245076" y="3227831"/>
+            <a:ext cx="164592" cy="27432"/>
           </a:xfrm>
           <a:prstGeom prst="downArrow">
             <a:avLst/>
@@ -9509,8 +9509,8 @@
         </p:nvSpPr>
         <p:spPr>
           <a:xfrm>
-            <a:off x="7174178" y="3127247"/>
-            <a:ext cx="2306388" cy="274320"/>
+            <a:off x="7174178" y="3264407"/>
+            <a:ext cx="2306388" cy="347472"/>
           </a:xfrm>
           <a:prstGeom prst="roundRect">
             <a:avLst/>
@@ -9553,7 +9553,7 @@
               <a:buNone/>
             </a:pPr>
             <a:r>
-              <a:rPr sz="950" b="1">
+              <a:rPr sz="1000" b="1">
                 <a:solidFill>
                   <a:srgbClr val="111B2A"/>
                 </a:solidFill>
@@ -9573,7 +9573,7 @@
               <a:buNone/>
             </a:pPr>
             <a:r>
-              <a:rPr sz="750" b="0">
+              <a:rPr sz="850" b="0">
                 <a:solidFill>
                   <a:srgbClr val="4A5A70"/>
                 </a:solidFill>
@@ -9592,8 +9592,8 @@
         </p:nvSpPr>
         <p:spPr>
           <a:xfrm>
-            <a:off x="8245076" y="3410711"/>
-            <a:ext cx="164592" cy="54864"/>
+            <a:off x="8245076" y="3621023"/>
+            <a:ext cx="164592" cy="27432"/>
           </a:xfrm>
           <a:prstGeom prst="downArrow">
             <a:avLst/>
@@ -9636,8 +9636,8 @@
         </p:nvSpPr>
         <p:spPr>
           <a:xfrm>
-            <a:off x="7174178" y="3474719"/>
-            <a:ext cx="2306388" cy="274320"/>
+            <a:off x="7174178" y="3657599"/>
+            <a:ext cx="2306388" cy="347472"/>
           </a:xfrm>
           <a:prstGeom prst="roundRect">
             <a:avLst/>
@@ -9680,7 +9680,7 @@
               <a:buNone/>
             </a:pPr>
             <a:r>
-              <a:rPr sz="950" b="1">
+              <a:rPr sz="1000" b="1">
                 <a:solidFill>
                   <a:srgbClr val="111B2A"/>
                 </a:solidFill>
@@ -9700,7 +9700,7 @@
               <a:buNone/>
             </a:pPr>
             <a:r>
-              <a:rPr sz="750" b="0">
+              <a:rPr sz="850" b="0">
                 <a:solidFill>
                   <a:srgbClr val="4A5A70"/>
                 </a:solidFill>
@@ -9719,7 +9719,7 @@
         </p:nvSpPr>
         <p:spPr>
           <a:xfrm>
-            <a:off x="7174178" y="3803904"/>
+            <a:off x="7174178" y="4023360"/>
             <a:ext cx="2306388" cy="274320"/>
           </a:xfrm>
           <a:prstGeom prst="rect">
@@ -9763,7 +9763,7 @@
         <p:spPr>
           <a:xfrm>
             <a:off x="9718311" y="1335024"/>
-            <a:ext cx="2086592" cy="2743200"/>
+            <a:ext cx="2086592" cy="2962656"/>
           </a:xfrm>
           <a:prstGeom prst="roundRect">
             <a:avLst/>
@@ -9806,7 +9806,7 @@
               <a:buNone/>
             </a:pPr>
             <a:r>
-              <a:rPr sz="750" b="1">
+              <a:rPr sz="800" b="1">
                 <a:solidFill>
                   <a:srgbClr val="8A9BB0"/>
                 </a:solidFill>
@@ -9825,8 +9825,8 @@
         </p:nvSpPr>
         <p:spPr>
           <a:xfrm>
-            <a:off x="9809751" y="1636775"/>
-            <a:ext cx="1903712" cy="475488"/>
+            <a:off x="9809751" y="1673352"/>
+            <a:ext cx="1903712" cy="530352"/>
           </a:xfrm>
           <a:prstGeom prst="roundRect">
             <a:avLst/>
@@ -9869,7 +9869,7 @@
               <a:buNone/>
             </a:pPr>
             <a:r>
-              <a:rPr sz="950" b="1">
+              <a:rPr sz="1000" b="1">
                 <a:solidFill>
                   <a:srgbClr val="111B2A"/>
                 </a:solidFill>
@@ -9889,7 +9889,7 @@
               <a:buNone/>
             </a:pPr>
             <a:r>
-              <a:rPr sz="750" b="0">
+              <a:rPr sz="850" b="0">
                 <a:solidFill>
                   <a:srgbClr val="4A5A70"/>
                 </a:solidFill>
@@ -9908,7 +9908,7 @@
         </p:nvSpPr>
         <p:spPr>
           <a:xfrm>
-            <a:off x="10679311" y="2121407"/>
+            <a:off x="10679311" y="2212848"/>
             <a:ext cx="164592" cy="109728"/>
           </a:xfrm>
           <a:prstGeom prst="downArrow">
@@ -9952,8 +9952,8 @@
         </p:nvSpPr>
         <p:spPr>
           <a:xfrm>
-            <a:off x="9809751" y="2240279"/>
-            <a:ext cx="1903712" cy="475488"/>
+            <a:off x="9809751" y="2331720"/>
+            <a:ext cx="1903712" cy="530352"/>
           </a:xfrm>
           <a:prstGeom prst="roundRect">
             <a:avLst/>
@@ -9996,7 +9996,7 @@
               <a:buNone/>
             </a:pPr>
             <a:r>
-              <a:rPr sz="950" b="1">
+              <a:rPr sz="1000" b="1">
                 <a:solidFill>
                   <a:srgbClr val="111B2A"/>
                 </a:solidFill>
@@ -10016,7 +10016,7 @@
               <a:buNone/>
             </a:pPr>
             <a:r>
-              <a:rPr sz="750" b="0">
+              <a:rPr sz="850" b="0">
                 <a:solidFill>
                   <a:srgbClr val="4A5A70"/>
                 </a:solidFill>
@@ -10035,7 +10035,7 @@
         </p:nvSpPr>
         <p:spPr>
           <a:xfrm>
-            <a:off x="10679311" y="2724911"/>
+            <a:off x="10679311" y="2871216"/>
             <a:ext cx="164592" cy="109728"/>
           </a:xfrm>
           <a:prstGeom prst="downArrow">
@@ -10079,8 +10079,8 @@
         </p:nvSpPr>
         <p:spPr>
           <a:xfrm>
-            <a:off x="9809751" y="2843784"/>
-            <a:ext cx="1903712" cy="475488"/>
+            <a:off x="9809751" y="2990088"/>
+            <a:ext cx="1903712" cy="530352"/>
           </a:xfrm>
           <a:prstGeom prst="roundRect">
             <a:avLst/>
@@ -10123,7 +10123,7 @@
               <a:buNone/>
             </a:pPr>
             <a:r>
-              <a:rPr sz="950" b="1">
+              <a:rPr sz="1000" b="1">
                 <a:solidFill>
                   <a:srgbClr val="111B2A"/>
                 </a:solidFill>
@@ -10143,7 +10143,7 @@
               <a:buNone/>
             </a:pPr>
             <a:r>
-              <a:rPr sz="750" b="0">
+              <a:rPr sz="850" b="0">
                 <a:solidFill>
                   <a:srgbClr val="4A5A70"/>
                 </a:solidFill>
@@ -10162,7 +10162,7 @@
         </p:nvSpPr>
         <p:spPr>
           <a:xfrm>
-            <a:off x="10679311" y="3328415"/>
+            <a:off x="10679311" y="3529584"/>
             <a:ext cx="164592" cy="109728"/>
           </a:xfrm>
           <a:prstGeom prst="downArrow">
@@ -10206,8 +10206,8 @@
         </p:nvSpPr>
         <p:spPr>
           <a:xfrm>
-            <a:off x="9809751" y="3447288"/>
-            <a:ext cx="1903712" cy="475488"/>
+            <a:off x="9809751" y="3648456"/>
+            <a:ext cx="1903712" cy="530352"/>
           </a:xfrm>
           <a:prstGeom prst="roundRect">
             <a:avLst/>
@@ -10250,7 +10250,7 @@
               <a:buNone/>
             </a:pPr>
             <a:r>
-              <a:rPr sz="950" b="1">
+              <a:rPr sz="1000" b="1">
                 <a:solidFill>
                   <a:srgbClr val="111B2A"/>
                 </a:solidFill>
@@ -10270,7 +10270,7 @@
               <a:buNone/>
             </a:pPr>
             <a:r>
-              <a:rPr sz="750" b="0">
+              <a:rPr sz="850" b="0">
                 <a:solidFill>
                   <a:srgbClr val="4A5A70"/>
                 </a:solidFill>
@@ -10289,8 +10289,8 @@
         </p:nvSpPr>
         <p:spPr>
           <a:xfrm>
-            <a:off x="384048" y="4169663"/>
-            <a:ext cx="11420856" cy="658368"/>
+            <a:off x="384048" y="4389120"/>
+            <a:ext cx="11420856" cy="603504"/>
           </a:xfrm>
           <a:prstGeom prst="roundRect">
             <a:avLst/>
@@ -10333,7 +10333,7 @@
               <a:buNone/>
             </a:pPr>
             <a:r>
-              <a:rPr sz="750" b="1">
+              <a:rPr sz="800" b="1">
                 <a:solidFill>
                   <a:srgbClr val="8A9BB0"/>
                 </a:solidFill>
@@ -10352,8 +10352,8 @@
         </p:nvSpPr>
         <p:spPr>
           <a:xfrm>
-            <a:off x="512064" y="4407407"/>
-            <a:ext cx="1601724" cy="347472"/>
+            <a:off x="512064" y="4608576"/>
+            <a:ext cx="1601724" cy="329184"/>
           </a:xfrm>
           <a:prstGeom prst="roundRect">
             <a:avLst/>
@@ -10415,8 +10415,8 @@
         </p:nvSpPr>
         <p:spPr>
           <a:xfrm>
-            <a:off x="2424683" y="4407407"/>
-            <a:ext cx="1601724" cy="347472"/>
+            <a:off x="2424683" y="4608576"/>
+            <a:ext cx="1601724" cy="329184"/>
           </a:xfrm>
           <a:prstGeom prst="roundRect">
             <a:avLst/>
@@ -10478,8 +10478,8 @@
         </p:nvSpPr>
         <p:spPr>
           <a:xfrm>
-            <a:off x="4337304" y="4407407"/>
-            <a:ext cx="1601724" cy="347472"/>
+            <a:off x="4337304" y="4608576"/>
+            <a:ext cx="1601724" cy="329184"/>
           </a:xfrm>
           <a:prstGeom prst="roundRect">
             <a:avLst/>
@@ -10541,8 +10541,8 @@
         </p:nvSpPr>
         <p:spPr>
           <a:xfrm>
-            <a:off x="6249924" y="4407407"/>
-            <a:ext cx="1601724" cy="347472"/>
+            <a:off x="6249924" y="4608576"/>
+            <a:ext cx="1601724" cy="329184"/>
           </a:xfrm>
           <a:prstGeom prst="roundRect">
             <a:avLst/>
@@ -10604,8 +10604,8 @@
         </p:nvSpPr>
         <p:spPr>
           <a:xfrm>
-            <a:off x="8162543" y="4407407"/>
-            <a:ext cx="1601724" cy="347472"/>
+            <a:off x="8162543" y="4608576"/>
+            <a:ext cx="1601724" cy="329184"/>
           </a:xfrm>
           <a:prstGeom prst="roundRect">
             <a:avLst/>
@@ -10667,8 +10667,8 @@
         </p:nvSpPr>
         <p:spPr>
           <a:xfrm>
-            <a:off x="10075164" y="4407407"/>
-            <a:ext cx="1601724" cy="347472"/>
+            <a:off x="10075164" y="4608576"/>
+            <a:ext cx="1601724" cy="329184"/>
           </a:xfrm>
           <a:prstGeom prst="roundRect">
             <a:avLst/>
@@ -10730,7 +10730,7 @@
         </p:nvSpPr>
         <p:spPr>
           <a:xfrm>
-            <a:off x="2168652" y="4498847"/>
+            <a:off x="2168652" y="4690872"/>
             <a:ext cx="201168" cy="164592"/>
           </a:xfrm>
           <a:prstGeom prst="rightArrow">
@@ -10774,7 +10774,7 @@
         </p:nvSpPr>
         <p:spPr>
           <a:xfrm>
-            <a:off x="4081271" y="4498847"/>
+            <a:off x="4081271" y="4690872"/>
             <a:ext cx="201168" cy="164592"/>
           </a:xfrm>
           <a:prstGeom prst="rightArrow">
@@ -10818,7 +10818,7 @@
         </p:nvSpPr>
         <p:spPr>
           <a:xfrm>
-            <a:off x="5993892" y="4498847"/>
+            <a:off x="5993892" y="4690872"/>
             <a:ext cx="201168" cy="164592"/>
           </a:xfrm>
           <a:prstGeom prst="rightArrow">
@@ -10862,7 +10862,7 @@
         </p:nvSpPr>
         <p:spPr>
           <a:xfrm>
-            <a:off x="7906512" y="4498847"/>
+            <a:off x="7906512" y="4690872"/>
             <a:ext cx="201168" cy="164592"/>
           </a:xfrm>
           <a:prstGeom prst="rightArrow">
@@ -10906,7 +10906,7 @@
         </p:nvSpPr>
         <p:spPr>
           <a:xfrm>
-            <a:off x="9819132" y="4498847"/>
+            <a:off x="9819132" y="4690872"/>
             <a:ext cx="201168" cy="164592"/>
           </a:xfrm>
           <a:prstGeom prst="rightArrow">
@@ -10950,8 +10950,8 @@
         </p:nvSpPr>
         <p:spPr>
           <a:xfrm>
-            <a:off x="384048" y="4919472"/>
-            <a:ext cx="2167128" cy="694944"/>
+            <a:off x="384048" y="5084064"/>
+            <a:ext cx="2167128" cy="676656"/>
           </a:xfrm>
           <a:prstGeom prst="roundRect">
             <a:avLst/>
@@ -11033,8 +11033,8 @@
         </p:nvSpPr>
         <p:spPr>
           <a:xfrm>
-            <a:off x="2697480" y="4919472"/>
-            <a:ext cx="2167128" cy="694944"/>
+            <a:off x="2697480" y="5084064"/>
+            <a:ext cx="2167128" cy="676656"/>
           </a:xfrm>
           <a:prstGeom prst="roundRect">
             <a:avLst/>
@@ -11116,8 +11116,8 @@
         </p:nvSpPr>
         <p:spPr>
           <a:xfrm>
-            <a:off x="5010912" y="4919472"/>
-            <a:ext cx="2167128" cy="694944"/>
+            <a:off x="5010912" y="5084064"/>
+            <a:ext cx="2167128" cy="676656"/>
           </a:xfrm>
           <a:prstGeom prst="roundRect">
             <a:avLst/>
@@ -11199,8 +11199,8 @@
         </p:nvSpPr>
         <p:spPr>
           <a:xfrm>
-            <a:off x="7324344" y="4919472"/>
-            <a:ext cx="2167128" cy="694944"/>
+            <a:off x="7324344" y="5084064"/>
+            <a:ext cx="2167128" cy="676656"/>
           </a:xfrm>
           <a:prstGeom prst="roundRect">
             <a:avLst/>
@@ -11282,8 +11282,8 @@
         </p:nvSpPr>
         <p:spPr>
           <a:xfrm>
-            <a:off x="9637776" y="4919472"/>
-            <a:ext cx="2167128" cy="694944"/>
+            <a:off x="9637776" y="5084064"/>
+            <a:ext cx="2167128" cy="676656"/>
           </a:xfrm>
           <a:prstGeom prst="roundRect">
             <a:avLst/>
@@ -11365,7 +11365,7 @@
         </p:nvSpPr>
         <p:spPr>
           <a:xfrm>
-            <a:off x="384048" y="5687568"/>
+            <a:off x="384048" y="5833872"/>
             <a:ext cx="11420856" cy="310896"/>
           </a:xfrm>
           <a:prstGeom prst="rect">
@@ -15550,7 +15550,7 @@
               <a:buNone/>
             </a:pPr>
             <a:r>
-              <a:rPr sz="750" b="1">
+              <a:rPr sz="800" b="1">
                 <a:solidFill>
                   <a:srgbClr val="8A9BB0"/>
                 </a:solidFill>
@@ -15613,7 +15613,7 @@
               <a:buNone/>
             </a:pPr>
             <a:r>
-              <a:rPr sz="950" b="1">
+              <a:rPr sz="1000" b="1">
                 <a:solidFill>
                   <a:srgbClr val="111B2A"/>
                 </a:solidFill>
@@ -15633,7 +15633,7 @@
               <a:buNone/>
             </a:pPr>
             <a:r>
-              <a:rPr sz="850" b="0">
+              <a:rPr sz="900" b="0">
                 <a:solidFill>
                   <a:srgbClr val="4A5A70"/>
                 </a:solidFill>
@@ -15696,7 +15696,7 @@
               <a:buNone/>
             </a:pPr>
             <a:r>
-              <a:rPr sz="950" b="1">
+              <a:rPr sz="1000" b="1">
                 <a:solidFill>
                   <a:srgbClr val="111B2A"/>
                 </a:solidFill>
@@ -15716,7 +15716,7 @@
               <a:buNone/>
             </a:pPr>
             <a:r>
-              <a:rPr sz="850" b="0">
+              <a:rPr sz="900" b="0">
                 <a:solidFill>
                   <a:srgbClr val="4A5A70"/>
                 </a:solidFill>
@@ -15779,7 +15779,7 @@
               <a:buNone/>
             </a:pPr>
             <a:r>
-              <a:rPr sz="950" b="1">
+              <a:rPr sz="1000" b="1">
                 <a:solidFill>
                   <a:srgbClr val="111B2A"/>
                 </a:solidFill>
@@ -15799,7 +15799,7 @@
               <a:buNone/>
             </a:pPr>
             <a:r>
-              <a:rPr sz="850" b="0">
+              <a:rPr sz="900" b="0">
                 <a:solidFill>
                   <a:srgbClr val="4A5A70"/>
                 </a:solidFill>
@@ -15862,7 +15862,7 @@
               <a:buNone/>
             </a:pPr>
             <a:r>
-              <a:rPr sz="950" b="1">
+              <a:rPr sz="1000" b="1">
                 <a:solidFill>
                   <a:srgbClr val="111B2A"/>
                 </a:solidFill>
@@ -15882,7 +15882,7 @@
               <a:buNone/>
             </a:pPr>
             <a:r>
-              <a:rPr sz="850" b="0">
+              <a:rPr sz="900" b="0">
                 <a:solidFill>
                   <a:srgbClr val="4A5A70"/>
                 </a:solidFill>
@@ -15945,7 +15945,7 @@
               <a:buNone/>
             </a:pPr>
             <a:r>
-              <a:rPr sz="950" b="1">
+              <a:rPr sz="1000" b="1">
                 <a:solidFill>
                   <a:srgbClr val="111B2A"/>
                 </a:solidFill>
@@ -15965,7 +15965,7 @@
               <a:buNone/>
             </a:pPr>
             <a:r>
-              <a:rPr sz="850" b="0">
+              <a:rPr sz="900" b="0">
                 <a:solidFill>
                   <a:srgbClr val="4A5A70"/>
                 </a:solidFill>
@@ -16028,7 +16028,7 @@
               <a:buNone/>
             </a:pPr>
             <a:r>
-              <a:rPr sz="950" b="1">
+              <a:rPr sz="1000" b="1">
                 <a:solidFill>
                   <a:srgbClr val="111B2A"/>
                 </a:solidFill>
@@ -16048,7 +16048,7 @@
               <a:buNone/>
             </a:pPr>
             <a:r>
-              <a:rPr sz="850" b="0">
+              <a:rPr sz="900" b="0">
                 <a:solidFill>
                   <a:srgbClr val="4A5A70"/>
                 </a:solidFill>

</xml_diff>